<commit_message>
Update repo links after GitHub rename to Team-Barbie/cfc-26
Repo was renamed from vinhack-26 to cfc-26; update clone instructions,
in-app issues link, and the presentation's GitHub references.
</commit_message>
<xml_diff>
--- a/output/VisionLoop-CFC-Dashboard.pptx
+++ b/output/VisionLoop-CFC-Dashboard.pptx
@@ -762,7 +762,7 @@
           <a:lstStyle xmlns:a="http://schemas.openxmlformats.org/drawingml/2006/main"/>
           <a:p xmlns:a="http://schemas.openxmlformats.org/drawingml/2006/main">
             <a:r>
-              <a:t>Workflow: 1. Webcam frames enter useEyeTracker.ts. 2. MediaPipe yields landmarks. 3. eyeTracking.ts extracts and maps gaze using saved calibration. 4. OneEuro smoothing stabilizes position. 5. GazePhraseBoard.tsx turns zones and confirmation into phrase selection. 6. Speech synthesis speaks the final phrase. Sources: web/src/hooks/useEyeTracker.ts, web/src/lib/eyeTracking.ts, web/src/lib/oneEuro.ts, web/package.json. Runtime/model hosts: jsDelivr and Google storage. No API key is required. Repository: https://github.com/Team-Barbie/vinhack-26</a:t>
+              <a:t>Workflow: 1. Webcam frames enter useEyeTracker.ts. 2. MediaPipe yields landmarks. 3. eyeTracking.ts extracts and maps gaze using saved calibration. 4. OneEuro smoothing stabilizes position. 5. GazePhraseBoard.tsx turns zones and confirmation into phrase selection. 6. Speech synthesis speaks the final phrase. Sources: web/src/hooks/useEyeTracker.ts, web/src/lib/eyeTracking.ts, web/src/lib/oneEuro.ts, web/package.json. Runtime/model hosts: jsDelivr and Google storage. No API key is required. Repository: https://github.com/Team-Barbie/cfc-26</a:t>
             </a:r>
           </a:p>
         </p:txBody>
@@ -7837,7 +7837,7 @@
                 <a:ea typeface="Aristotelica Pro"/>
                 <a:cs typeface="Aristotelica Pro"/>
               </a:rPr>
-              <a:t>GitHub: github.com/Team-Barbie/vinhack-26</a:t>
+              <a:t>GitHub: github.com/Team-Barbie/cfc-26</a:t>
             </a:r>
           </a:p>
         </p:txBody>

</xml_diff>